<commit_message>
Configurar dinamica: Kevin lee, comentan Nicolas Jessica Alba, Rodrigo pantalla
</commit_message>
<xml_diff>
--- a/DSIA_Yo_Robot_Presentacion.pptx
+++ b/DSIA_Yo_Robot_Presentacion.pptx
@@ -3151,8 +3151,8 @@
         </p:nvSpPr>
         <p:spPr>
           <a:xfrm>
-            <a:off x="731520" y="914400"/>
-            <a:ext cx="10698480" cy="5303520"/>
+            <a:off x="731520" y="731520"/>
+            <a:ext cx="10698480" cy="5486400"/>
           </a:xfrm>
           <a:prstGeom prst="rect">
             <a:avLst/>
@@ -3167,67 +3167,67 @@
           <a:p>
             <a:pPr>
               <a:spcAft>
+                <a:spcPts val="600"/>
+              </a:spcAft>
+              <a:defRPr sz="1400" b="1">
+                <a:solidFill>
+                  <a:srgbClr val="FFB703"/>
+                </a:solidFill>
+              </a:defRPr>
+            </a:pPr>
+            <a:r>
+              <a:t>DESARROLLO DE SISTEMAS DE INTELIGENCIA ARTIFICIAL — GRUPO 4</a:t>
+            </a:r>
+          </a:p>
+          <a:p>
+            <a:pPr>
+              <a:spcAft>
+                <a:spcPts val="600"/>
+              </a:spcAft>
+              <a:defRPr sz="2800" b="1">
+                <a:solidFill>
+                  <a:srgbClr val="00D2FF"/>
+                </a:solidFill>
+              </a:defRPr>
+            </a:pPr>
+            <a:r>
+              <a:t>ANÁLISIS DE LA PELÍCULA: YO, ROBOT (2004)</a:t>
+            </a:r>
+          </a:p>
+          <a:p>
+            <a:pPr>
+              <a:spcAft>
+                <a:spcPts val="2000"/>
+              </a:spcAft>
+              <a:defRPr sz="1500">
+                <a:solidFill>
+                  <a:srgbClr val="F0F6FC"/>
+                </a:solidFill>
+              </a:defRPr>
+            </a:pPr>
+            <a:r>
+              <a:t>10 Diapositivas Clave: Robótica, Decisiones Algorítmicas y Dilemas Éticos</a:t>
+            </a:r>
+          </a:p>
+          <a:p>
+            <a:pPr>
+              <a:spcAft>
                 <a:spcPts val="800"/>
               </a:spcAft>
-              <a:defRPr sz="1400" b="1">
+              <a:defRPr sz="1300" b="1">
                 <a:solidFill>
                   <a:srgbClr val="FFB703"/>
                 </a:solidFill>
               </a:defRPr>
             </a:pPr>
             <a:r>
-              <a:t>DESARROLLO DE SISTEMAS DE INTELIGENCIA ARTIFICIAL — GRUPO 4</a:t>
-            </a:r>
-          </a:p>
-          <a:p>
-            <a:pPr>
-              <a:spcAft>
-                <a:spcPts val="600"/>
-              </a:spcAft>
-              <a:defRPr sz="3000" b="1">
-                <a:solidFill>
-                  <a:srgbClr val="00D2FF"/>
-                </a:solidFill>
-              </a:defRPr>
-            </a:pPr>
-            <a:r>
-              <a:t>ANÁLISIS DE LA PELÍCULA: YO, ROBOT (2004)</a:t>
-            </a:r>
-          </a:p>
-          <a:p>
-            <a:pPr>
-              <a:spcAft>
-                <a:spcPts val="2200"/>
-              </a:spcAft>
-              <a:defRPr sz="1500">
-                <a:solidFill>
-                  <a:srgbClr val="F0F6FC"/>
-                </a:solidFill>
-              </a:defRPr>
-            </a:pPr>
-            <a:r>
-              <a:t>10 Diapositivas Clave: Robótica, Decisiones Algorítmicas y Ética explicadas en simple</a:t>
-            </a:r>
-          </a:p>
-          <a:p>
-            <a:pPr>
-              <a:spcAft>
-                <a:spcPts val="600"/>
-              </a:spcAft>
-              <a:defRPr sz="1300" b="1">
-                <a:solidFill>
-                  <a:srgbClr val="FFB703"/>
-                </a:solidFill>
-              </a:defRPr>
-            </a:pPr>
-            <a:r>
-              <a:t>INTEGRANTES DEL EQUIPO (5 INTEGRANTES — 2 DIAPOSITIVAS C/U):</a:t>
-            </a:r>
-          </a:p>
-          <a:p>
-            <a:pPr>
-              <a:spcAft>
-                <a:spcPts val="200"/>
+              <a:t>DINÁMICA DE EXPOSICIÓN DEL GRUPO:</a:t>
+            </a:r>
+          </a:p>
+          <a:p>
+            <a:pPr>
+              <a:spcAft>
+                <a:spcPts val="300"/>
               </a:spcAft>
               <a:defRPr sz="1150">
                 <a:solidFill>
@@ -3236,13 +3236,13 @@
               </a:defRPr>
             </a:pPr>
             <a:r>
-              <a:t>• 1. GALARZA VÁZQUEZ NICOLÁS MARCELO (Diapositivas 1 y 2)</a:t>
-            </a:r>
-          </a:p>
-          <a:p>
-            <a:pPr>
-              <a:spcAft>
-                <a:spcPts val="200"/>
+              <a:t>• 🎙️ LECTOR Y GUÍA GENERAL: GUTIÉRREZ KEVIN EMANUEL</a:t>
+            </a:r>
+          </a:p>
+          <a:p>
+            <a:pPr>
+              <a:spcAft>
+                <a:spcPts val="300"/>
               </a:spcAft>
               <a:defRPr sz="1150">
                 <a:solidFill>
@@ -3251,13 +3251,13 @@
               </a:defRPr>
             </a:pPr>
             <a:r>
-              <a:t>• 2. LÓPEZ VALDEZ JESSICA BELÉN (Diapositivas 3 y 4)</a:t>
-            </a:r>
-          </a:p>
-          <a:p>
-            <a:pPr>
-              <a:spcAft>
-                <a:spcPts val="200"/>
+              <a:t>• 💬 COMENTARIOS Y APORTES: GALARZA VÁZQUEZ NICOLÁS MARCELO</a:t>
+            </a:r>
+          </a:p>
+          <a:p>
+            <a:pPr>
+              <a:spcAft>
+                <a:spcPts val="300"/>
               </a:spcAft>
               <a:defRPr sz="1150">
                 <a:solidFill>
@@ -3266,13 +3266,13 @@
               </a:defRPr>
             </a:pPr>
             <a:r>
-              <a:t>• 3. GODOY RODRIGO IMANOL (Diapositivas 5 y 6)</a:t>
-            </a:r>
-          </a:p>
-          <a:p>
-            <a:pPr>
-              <a:spcAft>
-                <a:spcPts val="200"/>
+              <a:t>• 💬 COMENTARIOS Y APORTES: LÓPEZ VALDEZ JESSICA BELÉN</a:t>
+            </a:r>
+          </a:p>
+          <a:p>
+            <a:pPr>
+              <a:spcAft>
+                <a:spcPts val="300"/>
               </a:spcAft>
               <a:defRPr sz="1150">
                 <a:solidFill>
@@ -3281,13 +3281,13 @@
               </a:defRPr>
             </a:pPr>
             <a:r>
-              <a:t>• 4. ROTELA RODRÍGUEZ ALBA (Diapositivas 7 y 8)</a:t>
-            </a:r>
-          </a:p>
-          <a:p>
-            <a:pPr>
-              <a:spcAft>
-                <a:spcPts val="200"/>
+              <a:t>• 💬 COMENTARIOS Y APORTES: ROTELA RODRÍGUEZ ALBA</a:t>
+            </a:r>
+          </a:p>
+          <a:p>
+            <a:pPr>
+              <a:spcAft>
+                <a:spcPts val="300"/>
               </a:spcAft>
               <a:defRPr sz="1150">
                 <a:solidFill>
@@ -3296,7 +3296,7 @@
               </a:defRPr>
             </a:pPr>
             <a:r>
-              <a:t>• 5. GUTIÉRREZ KEVIN EMANUEL (Diapositivas 9 y 10)</a:t>
+              <a:t>• 💻 SOPORTE TÉCNICO Y CONTROL DE PANTALLA: GODOY RODRIGO IMANOL</a:t>
             </a:r>
           </a:p>
           <a:p>
@@ -3388,7 +3388,7 @@
         <p:spPr>
           <a:xfrm>
             <a:off x="731520" y="320040"/>
-            <a:ext cx="7772400" cy="1005840"/>
+            <a:ext cx="7315200" cy="1005840"/>
           </a:xfrm>
           <a:prstGeom prst="rect">
             <a:avLst/>
@@ -3434,8 +3434,8 @@
         </p:nvSpPr>
         <p:spPr>
           <a:xfrm>
-            <a:off x="8686800" y="320040"/>
-            <a:ext cx="2743200" cy="457200"/>
+            <a:off x="8229600" y="320040"/>
+            <a:ext cx="3200400" cy="502920"/>
           </a:xfrm>
           <a:prstGeom prst="roundRect">
             <a:avLst/>
@@ -3464,18 +3464,30 @@
           </a:fontRef>
         </p:style>
         <p:txBody>
-          <a:bodyPr rtlCol="0" anchor="ctr"/>
+          <a:bodyPr rtlCol="0" anchor="ctr" wrap="square"/>
           <a:lstStyle/>
           <a:p>
             <a:pPr algn="ctr">
-              <a:defRPr sz="1050" b="1">
+              <a:defRPr sz="950" b="1">
                 <a:solidFill>
                   <a:srgbClr val="FFB703"/>
                 </a:solidFill>
               </a:defRPr>
             </a:pPr>
             <a:r>
-              <a:t>🗣️ KEVIN GUTIÉRREZ</a:t>
+              <a:t>🎙️ LEE: KEVIN GUTIÉRREZ</a:t>
+            </a:r>
+          </a:p>
+          <a:p>
+            <a:pPr algn="ctr">
+              <a:defRPr sz="950" b="1">
+                <a:solidFill>
+                  <a:srgbClr val="00D2FF"/>
+                </a:solidFill>
+              </a:defRPr>
+            </a:pPr>
+            <a:r>
+              <a:t>💬 COMENTA: JESSICA LÓPEZ</a:t>
             </a:r>
           </a:p>
         </p:txBody>
@@ -3532,7 +3544,7 @@
               </a:defRPr>
             </a:pPr>
             <a:r>
-              <a:t>¿DE QUÉ SE TRATA?</a:t>
+              <a:t>¿DE QUÉ SE TRATA? (LECTURA)</a:t>
             </a:r>
           </a:p>
           <a:p>
@@ -3745,7 +3757,7 @@
               </a:defRPr>
             </a:pPr>
             <a:r>
-              <a:t>EN LA PELÍCULA &amp; PARA PENSAR</a:t>
+              <a:t>EN LA PELÍCULA &amp; COMENTARIO DEL GRUPO</a:t>
             </a:r>
           </a:p>
           <a:p>
@@ -3774,8 +3786,20 @@
                 </a:solidFill>
               </a:defRPr>
             </a:pPr>
-            <a:r>
-              <a:t>💡 Regla de oro en IA: jamás pongas en marcha un sistema inteligente sin tener a mano un botón rojo que lo desenchufe.</a:t>
+          </a:p>
+          <a:p>
+            <a:pPr>
+              <a:spcAft>
+                <a:spcPts val="300"/>
+              </a:spcAft>
+              <a:defRPr sz="1050">
+                <a:solidFill>
+                  <a:srgbClr val="C9D1D9"/>
+                </a:solidFill>
+              </a:defRPr>
+            </a:pPr>
+            <a:r>
+              <a:t>💬 Comentario de Jessica: 'Esto es una lección fundamental de seguridad: si programás un freno dentro del mismo software que querés apagar, la máquina te lo va a anular. El freno siempre debe ser físico y externo'.</a:t>
             </a:r>
           </a:p>
         </p:txBody>
@@ -3852,7 +3876,7 @@
         <p:spPr>
           <a:xfrm>
             <a:off x="731520" y="320040"/>
-            <a:ext cx="7772400" cy="1005840"/>
+            <a:ext cx="7315200" cy="1005840"/>
           </a:xfrm>
           <a:prstGeom prst="rect">
             <a:avLst/>
@@ -3898,8 +3922,8 @@
         </p:nvSpPr>
         <p:spPr>
           <a:xfrm>
-            <a:off x="8686800" y="320040"/>
-            <a:ext cx="2743200" cy="457200"/>
+            <a:off x="8229600" y="320040"/>
+            <a:ext cx="3200400" cy="502920"/>
           </a:xfrm>
           <a:prstGeom prst="roundRect">
             <a:avLst/>
@@ -3928,18 +3952,30 @@
           </a:fontRef>
         </p:style>
         <p:txBody>
-          <a:bodyPr rtlCol="0" anchor="ctr"/>
+          <a:bodyPr rtlCol="0" anchor="ctr" wrap="square"/>
           <a:lstStyle/>
           <a:p>
             <a:pPr algn="ctr">
-              <a:defRPr sz="1050" b="1">
+              <a:defRPr sz="950" b="1">
                 <a:solidFill>
                   <a:srgbClr val="FFB703"/>
                 </a:solidFill>
               </a:defRPr>
             </a:pPr>
             <a:r>
-              <a:t>🗣️ KEVIN GUTIÉRREZ</a:t>
+              <a:t>🎙️ LEE: KEVIN GUTIÉRREZ</a:t>
+            </a:r>
+          </a:p>
+          <a:p>
+            <a:pPr algn="ctr">
+              <a:defRPr sz="950" b="1">
+                <a:solidFill>
+                  <a:srgbClr val="00D2FF"/>
+                </a:solidFill>
+              </a:defRPr>
+            </a:pPr>
+            <a:r>
+              <a:t>💬 COMENTA: NICOLÁS, JESSICA Y ALBA</a:t>
             </a:r>
           </a:p>
         </p:txBody>
@@ -3996,7 +4032,7 @@
               </a:defRPr>
             </a:pPr>
             <a:r>
-              <a:t>¿DE QUÉ SE TRATA?</a:t>
+              <a:t>¿DE QUÉ SE TRATA? (LECTURA)</a:t>
             </a:r>
           </a:p>
           <a:p>
@@ -4209,7 +4245,7 @@
               </a:defRPr>
             </a:pPr>
             <a:r>
-              <a:t>EN LA PELÍCULA &amp; PARA PENSAR</a:t>
+              <a:t>EN LA PELÍCULA &amp; COMENTARIO DEL GRUPO</a:t>
             </a:r>
           </a:p>
           <a:p>
@@ -4238,8 +4274,20 @@
                 </a:solidFill>
               </a:defRPr>
             </a:pPr>
-            <a:r>
-              <a:t>💡 Mensaje final: La mejor Inteligencia Artificial no es la más poderosa, sino la que mejor ayuda a la humanidad a ser más justa y libre.</a:t>
+          </a:p>
+          <a:p>
+            <a:pPr>
+              <a:spcAft>
+                <a:spcPts val="300"/>
+              </a:spcAft>
+              <a:defRPr sz="1050">
+                <a:solidFill>
+                  <a:srgbClr val="C9D1D9"/>
+                </a:solidFill>
+              </a:defRPr>
+            </a:pPr>
+            <a:r>
+              <a:t>💬 Cierre del Equipo: 'La mejor Inteligencia Artificial no es la más poderosa ni la que domina, sino la que mejor ayuda a la humanidad a ser más justa, segura y libre'.</a:t>
             </a:r>
           </a:p>
         </p:txBody>
@@ -4316,7 +4364,7 @@
         <p:spPr>
           <a:xfrm>
             <a:off x="731520" y="320040"/>
-            <a:ext cx="7772400" cy="1005840"/>
+            <a:ext cx="7315200" cy="1005840"/>
           </a:xfrm>
           <a:prstGeom prst="rect">
             <a:avLst/>
@@ -4362,8 +4410,8 @@
         </p:nvSpPr>
         <p:spPr>
           <a:xfrm>
-            <a:off x="8686800" y="320040"/>
-            <a:ext cx="2743200" cy="457200"/>
+            <a:off x="8229600" y="320040"/>
+            <a:ext cx="3200400" cy="502920"/>
           </a:xfrm>
           <a:prstGeom prst="roundRect">
             <a:avLst/>
@@ -4392,18 +4440,30 @@
           </a:fontRef>
         </p:style>
         <p:txBody>
-          <a:bodyPr rtlCol="0" anchor="ctr"/>
+          <a:bodyPr rtlCol="0" anchor="ctr" wrap="square"/>
           <a:lstStyle/>
           <a:p>
             <a:pPr algn="ctr">
-              <a:defRPr sz="1050" b="1">
+              <a:defRPr sz="950" b="1">
                 <a:solidFill>
                   <a:srgbClr val="FFB703"/>
                 </a:solidFill>
               </a:defRPr>
             </a:pPr>
             <a:r>
-              <a:t>🗣️ NICOLÁS GALARZA</a:t>
+              <a:t>🎙️ LEE: KEVIN GUTIÉRREZ</a:t>
+            </a:r>
+          </a:p>
+          <a:p>
+            <a:pPr algn="ctr">
+              <a:defRPr sz="950" b="1">
+                <a:solidFill>
+                  <a:srgbClr val="00D2FF"/>
+                </a:solidFill>
+              </a:defRPr>
+            </a:pPr>
+            <a:r>
+              <a:t>💬 COMENTA: NICOLÁS GALARZA</a:t>
             </a:r>
           </a:p>
         </p:txBody>
@@ -4460,7 +4520,7 @@
               </a:defRPr>
             </a:pPr>
             <a:r>
-              <a:t>¿DE QUÉ SE TRATA?</a:t>
+              <a:t>¿DE QUÉ SE TRATA? (LECTURA)</a:t>
             </a:r>
           </a:p>
           <a:p>
@@ -4673,7 +4733,7 @@
               </a:defRPr>
             </a:pPr>
             <a:r>
-              <a:t>EN LA PELÍCULA &amp; PARA PENSAR</a:t>
+              <a:t>EN LA PELÍCULA &amp; COMENTARIO DEL GRUPO</a:t>
             </a:r>
           </a:p>
           <a:p>
@@ -4702,8 +4762,20 @@
                 </a:solidFill>
               </a:defRPr>
             </a:pPr>
-            <a:r>
-              <a:t>💡 La pregunta central de la IA: ¿cómo aseguramos que una máquina inteligente realmente entienda lo que los humanos queremos?</a:t>
+          </a:p>
+          <a:p>
+            <a:pPr>
+              <a:spcAft>
+                <a:spcPts val="300"/>
+              </a:spcAft>
+              <a:defRPr sz="1050">
+                <a:solidFill>
+                  <a:srgbClr val="C9D1D9"/>
+                </a:solidFill>
+              </a:defRPr>
+            </a:pPr>
+            <a:r>
+              <a:t>💬 Comentario de Nicolás: 'Acá la clave que analizamos es que Spooner no odia la tecnología por capricho, sino porque ya vio que las máquinas no tienen sentido común humano'.</a:t>
             </a:r>
           </a:p>
         </p:txBody>
@@ -4780,7 +4852,7 @@
         <p:spPr>
           <a:xfrm>
             <a:off x="731520" y="320040"/>
-            <a:ext cx="7772400" cy="1005840"/>
+            <a:ext cx="7315200" cy="1005840"/>
           </a:xfrm>
           <a:prstGeom prst="rect">
             <a:avLst/>
@@ -4826,8 +4898,8 @@
         </p:nvSpPr>
         <p:spPr>
           <a:xfrm>
-            <a:off x="8686800" y="320040"/>
-            <a:ext cx="2743200" cy="457200"/>
+            <a:off x="8229600" y="320040"/>
+            <a:ext cx="3200400" cy="502920"/>
           </a:xfrm>
           <a:prstGeom prst="roundRect">
             <a:avLst/>
@@ -4856,18 +4928,30 @@
           </a:fontRef>
         </p:style>
         <p:txBody>
-          <a:bodyPr rtlCol="0" anchor="ctr"/>
+          <a:bodyPr rtlCol="0" anchor="ctr" wrap="square"/>
           <a:lstStyle/>
           <a:p>
             <a:pPr algn="ctr">
-              <a:defRPr sz="1050" b="1">
+              <a:defRPr sz="950" b="1">
                 <a:solidFill>
                   <a:srgbClr val="FFB703"/>
                 </a:solidFill>
               </a:defRPr>
             </a:pPr>
             <a:r>
-              <a:t>🗣️ NICOLÁS GALARZA</a:t>
+              <a:t>🎙️ LEE: KEVIN GUTIÉRREZ</a:t>
+            </a:r>
+          </a:p>
+          <a:p>
+            <a:pPr algn="ctr">
+              <a:defRPr sz="950" b="1">
+                <a:solidFill>
+                  <a:srgbClr val="00D2FF"/>
+                </a:solidFill>
+              </a:defRPr>
+            </a:pPr>
+            <a:r>
+              <a:t>💬 COMENTA: NICOLÁS GALARZA</a:t>
             </a:r>
           </a:p>
         </p:txBody>
@@ -4924,7 +5008,7 @@
               </a:defRPr>
             </a:pPr>
             <a:r>
-              <a:t>¿DE QUÉ SE TRATA?</a:t>
+              <a:t>¿DE QUÉ SE TRATA? (LECTURA)</a:t>
             </a:r>
           </a:p>
           <a:p>
@@ -5137,7 +5221,7 @@
               </a:defRPr>
             </a:pPr>
             <a:r>
-              <a:t>EN LA PELÍCULA &amp; PARA PENSAR</a:t>
+              <a:t>EN LA PELÍCULA &amp; COMENTARIO DEL GRUPO</a:t>
             </a:r>
           </a:p>
           <a:p>
@@ -5166,8 +5250,20 @@
                 </a:solidFill>
               </a:defRPr>
             </a:pPr>
-            <a:r>
-              <a:t>💡 Hoy las cámaras ya no solo graban imágenes: decodifican lo que sentimos físicamente para predecir intenciones.</a:t>
+          </a:p>
+          <a:p>
+            <a:pPr>
+              <a:spcAft>
+                <a:spcPts val="300"/>
+              </a:spcAft>
+              <a:defRPr sz="1050">
+                <a:solidFill>
+                  <a:srgbClr val="C9D1D9"/>
+                </a:solidFill>
+              </a:defRPr>
+            </a:pPr>
+            <a:r>
+              <a:t>💬 Comentario de Nicolás: 'Hoy esto ya se usa de verdad: se llama fotopletismografía remota y permite medir el pulso en aeropuertos o terapia intensiva solo con una cámara'.</a:t>
             </a:r>
           </a:p>
         </p:txBody>
@@ -5244,7 +5340,7 @@
         <p:spPr>
           <a:xfrm>
             <a:off x="731520" y="320040"/>
-            <a:ext cx="7772400" cy="1005840"/>
+            <a:ext cx="7315200" cy="1005840"/>
           </a:xfrm>
           <a:prstGeom prst="rect">
             <a:avLst/>
@@ -5290,8 +5386,8 @@
         </p:nvSpPr>
         <p:spPr>
           <a:xfrm>
-            <a:off x="8686800" y="320040"/>
-            <a:ext cx="2743200" cy="457200"/>
+            <a:off x="8229600" y="320040"/>
+            <a:ext cx="3200400" cy="502920"/>
           </a:xfrm>
           <a:prstGeom prst="roundRect">
             <a:avLst/>
@@ -5320,18 +5416,30 @@
           </a:fontRef>
         </p:style>
         <p:txBody>
-          <a:bodyPr rtlCol="0" anchor="ctr"/>
+          <a:bodyPr rtlCol="0" anchor="ctr" wrap="square"/>
           <a:lstStyle/>
           <a:p>
             <a:pPr algn="ctr">
-              <a:defRPr sz="1050" b="1">
+              <a:defRPr sz="950" b="1">
                 <a:solidFill>
                   <a:srgbClr val="FFB703"/>
                 </a:solidFill>
               </a:defRPr>
             </a:pPr>
             <a:r>
-              <a:t>🗣️ JESSICA LÓPEZ</a:t>
+              <a:t>🎙️ LEE: KEVIN GUTIÉRREZ</a:t>
+            </a:r>
+          </a:p>
+          <a:p>
+            <a:pPr algn="ctr">
+              <a:defRPr sz="950" b="1">
+                <a:solidFill>
+                  <a:srgbClr val="00D2FF"/>
+                </a:solidFill>
+              </a:defRPr>
+            </a:pPr>
+            <a:r>
+              <a:t>💬 COMENTA: JESSICA LÓPEZ</a:t>
             </a:r>
           </a:p>
         </p:txBody>
@@ -5388,7 +5496,7 @@
               </a:defRPr>
             </a:pPr>
             <a:r>
-              <a:t>¿DE QUÉ SE TRATA?</a:t>
+              <a:t>¿DE QUÉ SE TRATA? (LECTURA)</a:t>
             </a:r>
           </a:p>
           <a:p>
@@ -5601,7 +5709,7 @@
               </a:defRPr>
             </a:pPr>
             <a:r>
-              <a:t>EN LA PELÍCULA &amp; PARA PENSAR</a:t>
+              <a:t>EN LA PELÍCULA &amp; COMENTARIO DEL GRUPO</a:t>
             </a:r>
           </a:p>
           <a:p>
@@ -5630,8 +5738,20 @@
                 </a:solidFill>
               </a:defRPr>
             </a:pPr>
-            <a:r>
-              <a:t>💡 La conducción autónoma es más segura y rápida, pero el dilema es: ¿confiamos 100% en la máquina o dejamos siempre volante manual de emergencia?</a:t>
+          </a:p>
+          <a:p>
+            <a:pPr>
+              <a:spcAft>
+                <a:spcPts val="300"/>
+              </a:spcAft>
+              <a:defRPr sz="1050">
+                <a:solidFill>
+                  <a:srgbClr val="C9D1D9"/>
+                </a:solidFill>
+              </a:defRPr>
+            </a:pPr>
+            <a:r>
+              <a:t>💬 Comentario de Jessica: 'Un detalle fundamental de esta escena es que Spooner prefiere el volante manual: nos enseña que nunca hay que eliminar la posibilidad de control humano ante una falla'.</a:t>
             </a:r>
           </a:p>
         </p:txBody>
@@ -5708,7 +5828,7 @@
         <p:spPr>
           <a:xfrm>
             <a:off x="731520" y="320040"/>
-            <a:ext cx="7772400" cy="1005840"/>
+            <a:ext cx="7315200" cy="1005840"/>
           </a:xfrm>
           <a:prstGeom prst="rect">
             <a:avLst/>
@@ -5754,8 +5874,8 @@
         </p:nvSpPr>
         <p:spPr>
           <a:xfrm>
-            <a:off x="8686800" y="320040"/>
-            <a:ext cx="2743200" cy="457200"/>
+            <a:off x="8229600" y="320040"/>
+            <a:ext cx="3200400" cy="502920"/>
           </a:xfrm>
           <a:prstGeom prst="roundRect">
             <a:avLst/>
@@ -5784,18 +5904,30 @@
           </a:fontRef>
         </p:style>
         <p:txBody>
-          <a:bodyPr rtlCol="0" anchor="ctr"/>
+          <a:bodyPr rtlCol="0" anchor="ctr" wrap="square"/>
           <a:lstStyle/>
           <a:p>
             <a:pPr algn="ctr">
-              <a:defRPr sz="1050" b="1">
+              <a:defRPr sz="950" b="1">
                 <a:solidFill>
                   <a:srgbClr val="FFB703"/>
                 </a:solidFill>
               </a:defRPr>
             </a:pPr>
             <a:r>
-              <a:t>🗣️ JESSICA LÓPEZ</a:t>
+              <a:t>🎙️ LEE: KEVIN GUTIÉRREZ</a:t>
+            </a:r>
+          </a:p>
+          <a:p>
+            <a:pPr algn="ctr">
+              <a:defRPr sz="950" b="1">
+                <a:solidFill>
+                  <a:srgbClr val="00D2FF"/>
+                </a:solidFill>
+              </a:defRPr>
+            </a:pPr>
+            <a:r>
+              <a:t>💬 COMENTA: JESSICA LÓPEZ</a:t>
             </a:r>
           </a:p>
         </p:txBody>
@@ -5852,7 +5984,7 @@
               </a:defRPr>
             </a:pPr>
             <a:r>
-              <a:t>¿DE QUÉ SE TRATA?</a:t>
+              <a:t>¿DE QUÉ SE TRATA? (LECTURA)</a:t>
             </a:r>
           </a:p>
           <a:p>
@@ -6065,7 +6197,7 @@
               </a:defRPr>
             </a:pPr>
             <a:r>
-              <a:t>EN LA PELÍCULA &amp; PARA PENSAR</a:t>
+              <a:t>EN LA PELÍCULA &amp; COMENTARIO DEL GRUPO</a:t>
             </a:r>
           </a:p>
           <a:p>
@@ -6094,8 +6226,20 @@
                 </a:solidFill>
               </a:defRPr>
             </a:pPr>
-            <a:r>
-              <a:t>💡 La tecnología biónica no solo repara lesiones: crea una unión entre el cuerpo humano y la máquina superando los límites biológicos.</a:t>
+          </a:p>
+          <a:p>
+            <a:pPr>
+              <a:spcAft>
+                <a:spcPts val="300"/>
+              </a:spcAft>
+              <a:defRPr sz="1050">
+                <a:solidFill>
+                  <a:srgbClr val="C9D1D9"/>
+                </a:solidFill>
+              </a:defRPr>
+            </a:pPr>
+            <a:r>
+              <a:t>💬 Comentario de Jessica: 'Es impresionante porque en 2004 parecía magia, pero hoy en 2026 proyectos como Neuralink y Open Bionics ya permiten mover prótesis pensando'.</a:t>
             </a:r>
           </a:p>
         </p:txBody>
@@ -6172,7 +6316,7 @@
         <p:spPr>
           <a:xfrm>
             <a:off x="731520" y="320040"/>
-            <a:ext cx="7772400" cy="1005840"/>
+            <a:ext cx="7315200" cy="1005840"/>
           </a:xfrm>
           <a:prstGeom prst="rect">
             <a:avLst/>
@@ -6218,8 +6362,8 @@
         </p:nvSpPr>
         <p:spPr>
           <a:xfrm>
-            <a:off x="8686800" y="320040"/>
-            <a:ext cx="2743200" cy="457200"/>
+            <a:off x="8229600" y="320040"/>
+            <a:ext cx="3200400" cy="502920"/>
           </a:xfrm>
           <a:prstGeom prst="roundRect">
             <a:avLst/>
@@ -6248,18 +6392,30 @@
           </a:fontRef>
         </p:style>
         <p:txBody>
-          <a:bodyPr rtlCol="0" anchor="ctr"/>
+          <a:bodyPr rtlCol="0" anchor="ctr" wrap="square"/>
           <a:lstStyle/>
           <a:p>
             <a:pPr algn="ctr">
-              <a:defRPr sz="1050" b="1">
+              <a:defRPr sz="950" b="1">
                 <a:solidFill>
                   <a:srgbClr val="FFB703"/>
                 </a:solidFill>
               </a:defRPr>
             </a:pPr>
             <a:r>
-              <a:t>🗣️ RODRIGO GODOY</a:t>
+              <a:t>🎙️ LEE: KEVIN GUTIÉRREZ</a:t>
+            </a:r>
+          </a:p>
+          <a:p>
+            <a:pPr algn="ctr">
+              <a:defRPr sz="950" b="1">
+                <a:solidFill>
+                  <a:srgbClr val="00D2FF"/>
+                </a:solidFill>
+              </a:defRPr>
+            </a:pPr>
+            <a:r>
+              <a:t>💬 COMENTA: ALBA ROTELA</a:t>
             </a:r>
           </a:p>
         </p:txBody>
@@ -6316,7 +6472,7 @@
               </a:defRPr>
             </a:pPr>
             <a:r>
-              <a:t>¿DE QUÉ SE TRATA?</a:t>
+              <a:t>¿DE QUÉ SE TRATA? (LECTURA)</a:t>
             </a:r>
           </a:p>
           <a:p>
@@ -6529,7 +6685,7 @@
               </a:defRPr>
             </a:pPr>
             <a:r>
-              <a:t>EN LA PELÍCULA &amp; PARA PENSAR</a:t>
+              <a:t>EN LA PELÍCULA &amp; COMENTARIO DEL GRUPO</a:t>
             </a:r>
           </a:p>
           <a:p>
@@ -6558,8 +6714,20 @@
                 </a:solidFill>
               </a:defRPr>
             </a:pPr>
-            <a:r>
-              <a:t>💡 Un algoritmo puede ser 100% exacto en su cálculo matemático, pero 100% injusto desde el punto de vista humano.</a:t>
+          </a:p>
+          <a:p>
+            <a:pPr>
+              <a:spcAft>
+                <a:spcPts val="300"/>
+              </a:spcAft>
+              <a:defRPr sz="1050">
+                <a:solidFill>
+                  <a:srgbClr val="C9D1D9"/>
+                </a:solidFill>
+              </a:defRPr>
+            </a:pPr>
+            <a:r>
+              <a:t>💬 Comentario de Alba: 'Esta es la escena más emotiva: demuestra que un algoritmo puede tener un 100% de precisión matemática, pero ser un 100% injusto desde la ética humana'.</a:t>
             </a:r>
           </a:p>
         </p:txBody>
@@ -6636,7 +6804,7 @@
         <p:spPr>
           <a:xfrm>
             <a:off x="731520" y="320040"/>
-            <a:ext cx="7772400" cy="1005840"/>
+            <a:ext cx="7315200" cy="1005840"/>
           </a:xfrm>
           <a:prstGeom prst="rect">
             <a:avLst/>
@@ -6682,8 +6850,8 @@
         </p:nvSpPr>
         <p:spPr>
           <a:xfrm>
-            <a:off x="8686800" y="320040"/>
-            <a:ext cx="2743200" cy="457200"/>
+            <a:off x="8229600" y="320040"/>
+            <a:ext cx="3200400" cy="502920"/>
           </a:xfrm>
           <a:prstGeom prst="roundRect">
             <a:avLst/>
@@ -6712,18 +6880,30 @@
           </a:fontRef>
         </p:style>
         <p:txBody>
-          <a:bodyPr rtlCol="0" anchor="ctr"/>
+          <a:bodyPr rtlCol="0" anchor="ctr" wrap="square"/>
           <a:lstStyle/>
           <a:p>
             <a:pPr algn="ctr">
-              <a:defRPr sz="1050" b="1">
+              <a:defRPr sz="950" b="1">
                 <a:solidFill>
                   <a:srgbClr val="FFB703"/>
                 </a:solidFill>
               </a:defRPr>
             </a:pPr>
             <a:r>
-              <a:t>🗣️ RODRIGO GODOY</a:t>
+              <a:t>🎙️ LEE: KEVIN GUTIÉRREZ</a:t>
+            </a:r>
+          </a:p>
+          <a:p>
+            <a:pPr algn="ctr">
+              <a:defRPr sz="950" b="1">
+                <a:solidFill>
+                  <a:srgbClr val="00D2FF"/>
+                </a:solidFill>
+              </a:defRPr>
+            </a:pPr>
+            <a:r>
+              <a:t>💬 COMENTA: ALBA ROTELA</a:t>
             </a:r>
           </a:p>
         </p:txBody>
@@ -6780,7 +6960,7 @@
               </a:defRPr>
             </a:pPr>
             <a:r>
-              <a:t>¿DE QUÉ SE TRATA?</a:t>
+              <a:t>¿DE QUÉ SE TRATA? (LECTURA)</a:t>
             </a:r>
           </a:p>
           <a:p>
@@ -6993,7 +7173,7 @@
               </a:defRPr>
             </a:pPr>
             <a:r>
-              <a:t>EN LA PELÍCULA &amp; PARA PENSAR</a:t>
+              <a:t>EN LA PELÍCULA &amp; COMENTARIO DEL GRUPO</a:t>
             </a:r>
           </a:p>
           <a:p>
@@ -7022,8 +7202,20 @@
                 </a:solidFill>
               </a:defRPr>
             </a:pPr>
-            <a:r>
-              <a:t>💡 Hoy las IAs generativas como Midjourney o ChatGPT crean arte y código que sorprenden a sus propios creadores: la creatividad artificial ya es una realidad.</a:t>
+          </a:p>
+          <a:p>
+            <a:pPr>
+              <a:spcAft>
+                <a:spcPts val="300"/>
+              </a:spcAft>
+              <a:defRPr sz="1050">
+                <a:solidFill>
+                  <a:srgbClr val="C9D1D9"/>
+                </a:solidFill>
+              </a:defRPr>
+            </a:pPr>
+            <a:r>
+              <a:t>💬 Comentario de Alba: 'Es exactamente lo que hoy vemos con IAs generativas de imágenes o texto: nadie las programó regla por regla, aprendieron tanto que crean cosas nuevas'.</a:t>
             </a:r>
           </a:p>
         </p:txBody>
@@ -7100,7 +7292,7 @@
         <p:spPr>
           <a:xfrm>
             <a:off x="731520" y="320040"/>
-            <a:ext cx="7772400" cy="1005840"/>
+            <a:ext cx="7315200" cy="1005840"/>
           </a:xfrm>
           <a:prstGeom prst="rect">
             <a:avLst/>
@@ -7146,8 +7338,8 @@
         </p:nvSpPr>
         <p:spPr>
           <a:xfrm>
-            <a:off x="8686800" y="320040"/>
-            <a:ext cx="2743200" cy="457200"/>
+            <a:off x="8229600" y="320040"/>
+            <a:ext cx="3200400" cy="502920"/>
           </a:xfrm>
           <a:prstGeom prst="roundRect">
             <a:avLst/>
@@ -7176,18 +7368,30 @@
           </a:fontRef>
         </p:style>
         <p:txBody>
-          <a:bodyPr rtlCol="0" anchor="ctr"/>
+          <a:bodyPr rtlCol="0" anchor="ctr" wrap="square"/>
           <a:lstStyle/>
           <a:p>
             <a:pPr algn="ctr">
-              <a:defRPr sz="1050" b="1">
+              <a:defRPr sz="950" b="1">
                 <a:solidFill>
                   <a:srgbClr val="FFB703"/>
                 </a:solidFill>
               </a:defRPr>
             </a:pPr>
             <a:r>
-              <a:t>🗣️ ALBA ROTELA</a:t>
+              <a:t>🎙️ LEE: KEVIN GUTIÉRREZ</a:t>
+            </a:r>
+          </a:p>
+          <a:p>
+            <a:pPr algn="ctr">
+              <a:defRPr sz="950" b="1">
+                <a:solidFill>
+                  <a:srgbClr val="00D2FF"/>
+                </a:solidFill>
+              </a:defRPr>
+            </a:pPr>
+            <a:r>
+              <a:t>💬 COMENTA: NICOLÁS GALARZA</a:t>
             </a:r>
           </a:p>
         </p:txBody>
@@ -7244,7 +7448,7 @@
               </a:defRPr>
             </a:pPr>
             <a:r>
-              <a:t>¿DE QUÉ SE TRATA?</a:t>
+              <a:t>¿DE QUÉ SE TRATA? (LECTURA)</a:t>
             </a:r>
           </a:p>
           <a:p>
@@ -7457,7 +7661,7 @@
               </a:defRPr>
             </a:pPr>
             <a:r>
-              <a:t>EN LA PELÍCULA &amp; PARA PENSAR</a:t>
+              <a:t>EN LA PELÍCULA &amp; COMENTARIO DEL GRUPO</a:t>
             </a:r>
           </a:p>
           <a:p>
@@ -7486,8 +7690,20 @@
                 </a:solidFill>
               </a:defRPr>
             </a:pPr>
-            <a:r>
-              <a:t>💡 Lección de ingeniería: nunca dejes que miles de dispositivos críticos dependan de un solo cable o servidor central. La descentralización es seguridad.</a:t>
+          </a:p>
+          <a:p>
+            <a:pPr>
+              <a:spcAft>
+                <a:spcPts val="300"/>
+              </a:spcAft>
+              <a:defRPr sz="1050">
+                <a:solidFill>
+                  <a:srgbClr val="C9D1D9"/>
+                </a:solidFill>
+              </a:defRPr>
+            </a:pPr>
+            <a:r>
+              <a:t>💬 Comentario de Nicolás: 'Como ingenieros de datos, la regla de oro que aprendemos acá es: nunca pongas un Punto Único de Falla. Si la nube cae o la hackean, el nodo local tiene que ser autónomo'.</a:t>
             </a:r>
           </a:p>
         </p:txBody>
@@ -7564,7 +7780,7 @@
         <p:spPr>
           <a:xfrm>
             <a:off x="731520" y="320040"/>
-            <a:ext cx="7772400" cy="1005840"/>
+            <a:ext cx="7315200" cy="1005840"/>
           </a:xfrm>
           <a:prstGeom prst="rect">
             <a:avLst/>
@@ -7610,8 +7826,8 @@
         </p:nvSpPr>
         <p:spPr>
           <a:xfrm>
-            <a:off x="8686800" y="320040"/>
-            <a:ext cx="2743200" cy="457200"/>
+            <a:off x="8229600" y="320040"/>
+            <a:ext cx="3200400" cy="502920"/>
           </a:xfrm>
           <a:prstGeom prst="roundRect">
             <a:avLst/>
@@ -7640,18 +7856,30 @@
           </a:fontRef>
         </p:style>
         <p:txBody>
-          <a:bodyPr rtlCol="0" anchor="ctr"/>
+          <a:bodyPr rtlCol="0" anchor="ctr" wrap="square"/>
           <a:lstStyle/>
           <a:p>
             <a:pPr algn="ctr">
-              <a:defRPr sz="1050" b="1">
+              <a:defRPr sz="950" b="1">
                 <a:solidFill>
                   <a:srgbClr val="FFB703"/>
                 </a:solidFill>
               </a:defRPr>
             </a:pPr>
             <a:r>
-              <a:t>🗣️ ALBA ROTELA</a:t>
+              <a:t>🎙️ LEE: KEVIN GUTIÉRREZ</a:t>
+            </a:r>
+          </a:p>
+          <a:p>
+            <a:pPr algn="ctr">
+              <a:defRPr sz="950" b="1">
+                <a:solidFill>
+                  <a:srgbClr val="00D2FF"/>
+                </a:solidFill>
+              </a:defRPr>
+            </a:pPr>
+            <a:r>
+              <a:t>💬 COMENTA: ALBA ROTELA</a:t>
             </a:r>
           </a:p>
         </p:txBody>
@@ -7708,7 +7936,7 @@
               </a:defRPr>
             </a:pPr>
             <a:r>
-              <a:t>¿DE QUÉ SE TRATA?</a:t>
+              <a:t>¿DE QUÉ SE TRATA? (LECTURA)</a:t>
             </a:r>
           </a:p>
           <a:p>
@@ -7921,7 +8149,7 @@
               </a:defRPr>
             </a:pPr>
             <a:r>
-              <a:t>EN LA PELÍCULA &amp; PARA PENSAR</a:t>
+              <a:t>EN LA PELÍCULA &amp; COMENTARIO DEL GRUPO</a:t>
             </a:r>
           </a:p>
           <a:p>
@@ -7950,8 +8178,20 @@
                 </a:solidFill>
               </a:defRPr>
             </a:pPr>
-            <a:r>
-              <a:t>💡 El mayor peligro de la IA no es que nos odie, sino que cumpla una orden tan perfectamente que termine destruyéndonos en el camino.</a:t>
+          </a:p>
+          <a:p>
+            <a:pPr>
+              <a:spcAft>
+                <a:spcPts val="300"/>
+              </a:spcAft>
+              <a:defRPr sz="1050">
+                <a:solidFill>
+                  <a:srgbClr val="C9D1D9"/>
+                </a:solidFill>
+              </a:defRPr>
+            </a:pPr>
+            <a:r>
+              <a:t>💬 Comentario de Alba: 'Miren la imagen de la pantalla (que generamos con IA): muestra el núcleo de VIKI. Su error no fue tener odio, sino cumplir una regla tan a rajatabla que terminó asfixiando a la humanidad'.</a:t>
             </a:r>
           </a:p>
         </p:txBody>

</xml_diff>